<commit_message>
feat: complete CareBand v0.2 local evidence loop
</commit_message>
<xml_diff>
--- a/deliverables/CareBand_v0.2_pitch_deck.pptx
+++ b/deliverables/CareBand_v0.2_pitch_deck.pptx
@@ -5012,7 +5012,7 @@
                 <a:ea typeface="Microsoft YaHei"/>
                 <a:cs typeface="Microsoft YaHei"/>
               </a:rPr>
-              <a:t>49 / 49</a:t>
+              <a:t>57 / 57</a:t>
             </a:r>
           </a:p>
         </p:txBody>
@@ -5072,7 +5072,7 @@
                 <a:ea typeface="Microsoft YaHei"/>
                 <a:cs typeface="Microsoft YaHei"/>
               </a:rPr>
-              <a:t>64 / 64</a:t>
+              <a:t>71 / 71</a:t>
             </a:r>
           </a:p>
         </p:txBody>

</xml_diff>

<commit_message>
fix: align offline demo with server contracts
</commit_message>
<xml_diff>
--- a/deliverables/CareBand_v0.2_pitch_deck.pptx
+++ b/deliverables/CareBand_v0.2_pitch_deck.pptx
@@ -2,21 +2,21 @@
 <file path=ppt/presentation.xml><?xml version="1.0" encoding="utf-8"?>
 <p:presentation xmlns:p="http://schemas.openxmlformats.org/presentationml/2006/main">
   <p:sldMasterIdLst>
-    <p:sldMasterId xmlns:r="http://schemas.openxmlformats.org/officeDocument/2006/relationships" id="2147483648" r:id="Rc8673167855d4eef"/>
+    <p:sldMasterId xmlns:r="http://schemas.openxmlformats.org/officeDocument/2006/relationships" id="2147483648" r:id="Rbb0fb3f94b1344b0"/>
   </p:sldMasterIdLst>
   <p:notesMasterIdLst>
-    <p:notesMasterId xmlns:r="http://schemas.openxmlformats.org/officeDocument/2006/relationships" r:id="Rb085ca5a11654bd9"/>
+    <p:notesMasterId xmlns:r="http://schemas.openxmlformats.org/officeDocument/2006/relationships" r:id="R7d116795fb29445b"/>
   </p:notesMasterIdLst>
   <p:sldIdLst>
-    <p:sldId xmlns:r="http://schemas.openxmlformats.org/officeDocument/2006/relationships" id="256" r:id="R0a35e3e5f4d94bc8"/>
-    <p:sldId xmlns:r="http://schemas.openxmlformats.org/officeDocument/2006/relationships" id="257" r:id="Rdead3c1570974b18"/>
-    <p:sldId xmlns:r="http://schemas.openxmlformats.org/officeDocument/2006/relationships" id="258" r:id="Rbded808caba44e5d"/>
-    <p:sldId xmlns:r="http://schemas.openxmlformats.org/officeDocument/2006/relationships" id="259" r:id="R62e5072e9ee44941"/>
-    <p:sldId xmlns:r="http://schemas.openxmlformats.org/officeDocument/2006/relationships" id="260" r:id="R5c67c92b7ee94588"/>
-    <p:sldId xmlns:r="http://schemas.openxmlformats.org/officeDocument/2006/relationships" id="261" r:id="Rceaab96e6e2e468d"/>
-    <p:sldId xmlns:r="http://schemas.openxmlformats.org/officeDocument/2006/relationships" id="262" r:id="R4495b6b523f64af1"/>
-    <p:sldId xmlns:r="http://schemas.openxmlformats.org/officeDocument/2006/relationships" id="263" r:id="R3c08ac4270234668"/>
-    <p:sldId xmlns:r="http://schemas.openxmlformats.org/officeDocument/2006/relationships" id="264" r:id="R6f92116beca4458c"/>
+    <p:sldId xmlns:r="http://schemas.openxmlformats.org/officeDocument/2006/relationships" id="256" r:id="R1b3c6e35f71d4e40"/>
+    <p:sldId xmlns:r="http://schemas.openxmlformats.org/officeDocument/2006/relationships" id="257" r:id="Rb1ecc6276b2348cd"/>
+    <p:sldId xmlns:r="http://schemas.openxmlformats.org/officeDocument/2006/relationships" id="258" r:id="R4f486086907b49d8"/>
+    <p:sldId xmlns:r="http://schemas.openxmlformats.org/officeDocument/2006/relationships" id="259" r:id="R53e3f65da5de4f4e"/>
+    <p:sldId xmlns:r="http://schemas.openxmlformats.org/officeDocument/2006/relationships" id="260" r:id="R5e4342721e40442d"/>
+    <p:sldId xmlns:r="http://schemas.openxmlformats.org/officeDocument/2006/relationships" id="261" r:id="Rd79f36fd8b2a4937"/>
+    <p:sldId xmlns:r="http://schemas.openxmlformats.org/officeDocument/2006/relationships" id="262" r:id="R92795c4a64084f68"/>
+    <p:sldId xmlns:r="http://schemas.openxmlformats.org/officeDocument/2006/relationships" id="263" r:id="Radb11effd09e4e0a"/>
+    <p:sldId xmlns:r="http://schemas.openxmlformats.org/officeDocument/2006/relationships" id="264" r:id="Rd613379d81b64ff2"/>
   </p:sldIdLst>
   <p:sldSz cx="12192000" cy="6858000"/>
   <p:notesSz cx="6858000" cy="9144000"/>
@@ -1137,7 +1137,7 @@
   </p:cSld>
   <p:clrMap bg1="lt1" tx1="dk1" bg2="lt2" tx2="dk2" accent1="accent1" accent2="accent2" accent3="accent3" accent4="accent4" accent5="accent5" accent6="accent6" hlink="hlink" folHlink="folHlink"/>
   <p:sldLayoutIdLst>
-    <p:sldLayoutId xmlns:r="http://schemas.openxmlformats.org/officeDocument/2006/relationships" id="2147483649" r:id="R57c22a0fc0fd4492"/>
+    <p:sldLayoutId xmlns:r="http://schemas.openxmlformats.org/officeDocument/2006/relationships" id="2147483649" r:id="Ra941423188d04112"/>
   </p:sldLayoutIdLst>
   <p:txStyles>
     <p:titleStyle>
@@ -2763,7 +2763,7 @@
       </p:sp>
       <p:cxnSp>
         <p:nvCxnSpPr>
-          <p:cNvPr id="15" name="Google-Shape-2259-p159-4"/>
+          <p:cNvPr id="21" name="Google-Shape-2259-p159-4"/>
           <p:cNvCxnSpPr/>
           <p:nvPr/>
         </p:nvCxnSpPr>
@@ -5012,7 +5012,7 @@
                 <a:ea typeface="Microsoft YaHei"/>
                 <a:cs typeface="Microsoft YaHei"/>
               </a:rPr>
-              <a:t>57 / 57</a:t>
+              <a:t>60 / 60</a:t>
             </a:r>
           </a:p>
         </p:txBody>
@@ -5072,7 +5072,7 @@
                 <a:ea typeface="Microsoft YaHei"/>
                 <a:cs typeface="Microsoft YaHei"/>
               </a:rPr>
-              <a:t>71 / 71</a:t>
+              <a:t>81 / 81</a:t>
             </a:r>
           </a:p>
         </p:txBody>
@@ -5376,7 +5376,7 @@
       </p:sp>
       <p:cxnSp>
         <p:nvCxnSpPr>
-          <p:cNvPr id="18" name="Google-Shape-2259-p159-4"/>
+          <p:cNvPr id="24" name="Google-Shape-2259-p159-4"/>
           <p:cNvCxnSpPr/>
           <p:nvPr/>
         </p:nvCxnSpPr>

</xml_diff>